<commit_message>
Schulung: Einordnung erst beim Teilen, Vertrauensnetzwerk
Folien 7, 9, 15 und 19 an die Einordnung im Shop angepasst, Folie 16 nennt
das Vertrauensnetzwerk. „⋯“ auf Folie 15 durch „…“ ersetzt – Carlito hat
das Zeichen nicht, im PDF stand ein leeres Kästchen.

Co-Authored-By: Claude Opus 5.5 <noreply@anthropic.com>
</commit_message>
<xml_diff>
--- a/schulung/LearningModules-Schulung.pptx
+++ b/schulung/LearningModules-Schulung.pptx
@@ -3,28 +3,30 @@
 <p:presentation xmlns:a="http://schemas.openxmlformats.org/drawingml/2006/main" xmlns:p="http://schemas.openxmlformats.org/presentationml/2006/main" xmlns:r="http://schemas.openxmlformats.org/officeDocument/2006/relationships" xmlns:p14="http://schemas.microsoft.com/office/powerpoint/2010/main" xmlns:p15="http://schemas.microsoft.com/office/powerpoint/2012/main" xmlns:mc="http://schemas.openxmlformats.org/markup-compatibility/2006">
   <p:sldMasterIdLst>
     <p:sldMasterId id="2147483648" r:id="rId2"/>
+    <p:sldMasterId id="2147483650" r:id="rId3"/>
+    <p:sldMasterId id="2147483652" r:id="rId4"/>
   </p:sldMasterIdLst>
   <p:sldIdLst>
-    <p:sldId id="256" r:id="rId3"/>
-    <p:sldId id="257" r:id="rId4"/>
-    <p:sldId id="258" r:id="rId5"/>
-    <p:sldId id="259" r:id="rId6"/>
-    <p:sldId id="260" r:id="rId7"/>
-    <p:sldId id="261" r:id="rId8"/>
-    <p:sldId id="262" r:id="rId9"/>
-    <p:sldId id="263" r:id="rId10"/>
-    <p:sldId id="264" r:id="rId11"/>
-    <p:sldId id="265" r:id="rId12"/>
-    <p:sldId id="266" r:id="rId13"/>
-    <p:sldId id="267" r:id="rId14"/>
-    <p:sldId id="268" r:id="rId15"/>
-    <p:sldId id="269" r:id="rId16"/>
-    <p:sldId id="270" r:id="rId17"/>
-    <p:sldId id="271" r:id="rId18"/>
-    <p:sldId id="272" r:id="rId19"/>
-    <p:sldId id="273" r:id="rId20"/>
-    <p:sldId id="274" r:id="rId21"/>
-    <p:sldId id="275" r:id="rId22"/>
+    <p:sldId id="256" r:id="rId5"/>
+    <p:sldId id="257" r:id="rId6"/>
+    <p:sldId id="258" r:id="rId7"/>
+    <p:sldId id="259" r:id="rId8"/>
+    <p:sldId id="260" r:id="rId9"/>
+    <p:sldId id="261" r:id="rId10"/>
+    <p:sldId id="262" r:id="rId11"/>
+    <p:sldId id="263" r:id="rId12"/>
+    <p:sldId id="264" r:id="rId13"/>
+    <p:sldId id="265" r:id="rId14"/>
+    <p:sldId id="266" r:id="rId15"/>
+    <p:sldId id="267" r:id="rId16"/>
+    <p:sldId id="268" r:id="rId17"/>
+    <p:sldId id="269" r:id="rId18"/>
+    <p:sldId id="270" r:id="rId19"/>
+    <p:sldId id="271" r:id="rId20"/>
+    <p:sldId id="272" r:id="rId21"/>
+    <p:sldId id="273" r:id="rId22"/>
+    <p:sldId id="274" r:id="rId23"/>
+    <p:sldId id="275" r:id="rId24"/>
   </p:sldIdLst>
   <p:sldSz cx="10080625" cy="5670550"/>
   <p:notesSz cx="7559675" cy="10691813"/>
@@ -34,6 +36,159 @@
 <file path=ppt/slideLayouts/slideLayout1.xml><?xml version="1.0" encoding="utf-8"?>
 <p:sldLayout xmlns:a="http://schemas.openxmlformats.org/drawingml/2006/main" xmlns:p="http://schemas.openxmlformats.org/presentationml/2006/main" xmlns:r="http://schemas.openxmlformats.org/officeDocument/2006/relationships" xmlns:p14="http://schemas.microsoft.com/office/powerpoint/2010/main" xmlns:p15="http://schemas.microsoft.com/office/powerpoint/2012/main" xmlns:mc="http://schemas.openxmlformats.org/markup-compatibility/2006" type="title" preserve="1">
   <p:cSld name="Titel">
+    <p:spTree>
+      <p:nvGrpSpPr>
+        <p:cNvPr id="1" name=""/>
+        <p:cNvGrpSpPr/>
+        <p:nvPr/>
+      </p:nvGrpSpPr>
+      <p:grpSpPr>
+        <a:xfrm>
+          <a:off x="0" y="0"/>
+          <a:ext cx="0" cy="0"/>
+          <a:chOff x="0" y="0"/>
+          <a:chExt cx="0" cy="0"/>
+        </a:xfrm>
+      </p:grpSpPr>
+      <p:sp>
+        <p:nvSpPr>
+          <p:cNvPr id="6" name="PlaceHolder 1"/>
+          <p:cNvSpPr>
+            <a:spLocks noGrp="1"/>
+          </p:cNvSpPr>
+          <p:nvPr>
+            <p:ph type="title"/>
+          </p:nvPr>
+        </p:nvSpPr>
+        <p:spPr>
+          <a:xfrm>
+            <a:off x="576000" y="252000"/>
+            <a:ext cx="8928000" cy="684000"/>
+          </a:xfrm>
+          <a:prstGeom prst="rect">
+            <a:avLst/>
+          </a:prstGeom>
+          <a:noFill/>
+          <a:ln w="0">
+            <a:noFill/>
+          </a:ln>
+        </p:spPr>
+        <p:txBody>
+          <a:bodyPr lIns="0" tIns="0" rIns="0" bIns="0" anchor="b">
+            <a:noAutofit/>
+          </a:bodyPr>
+          <a:p>
+            <a:pPr indent="0" algn="l">
+              <a:buNone/>
+            </a:pPr>
+            <a:endParaRPr lang="de-DE" sz="3400" b="1" u="none" strike="noStrike">
+              <a:solidFill>
+                <a:srgbClr val="1E293B"/>
+              </a:solidFill>
+              <a:effectLst/>
+              <a:uFillTx/>
+              <a:latin typeface="Calibri"/>
+            </a:endParaRPr>
+          </a:p>
+        </p:txBody>
+      </p:sp>
+      <p:sp>
+        <p:nvSpPr>
+          <p:cNvPr id="7" name="PlaceHolder 2"/>
+          <p:cNvSpPr>
+            <a:spLocks noGrp="1"/>
+          </p:cNvSpPr>
+          <p:nvPr>
+            <p:ph type="subTitle"/>
+          </p:nvPr>
+        </p:nvSpPr>
+        <p:spPr>
+          <a:xfrm>
+            <a:off x="576000" y="1206000"/>
+            <a:ext cx="8928000" cy="3852000"/>
+          </a:xfrm>
+          <a:prstGeom prst="rect">
+            <a:avLst/>
+          </a:prstGeom>
+          <a:noFill/>
+          <a:ln w="0">
+            <a:noFill/>
+          </a:ln>
+        </p:spPr>
+        <p:txBody>
+          <a:bodyPr lIns="0" tIns="0" rIns="0" bIns="0" anchor="t">
+            <a:spAutoFit/>
+          </a:bodyPr>
+          <a:p>
+            <a:pPr indent="0" algn="l">
+              <a:lnSpc>
+                <a:spcPct val="115000"/>
+              </a:lnSpc>
+              <a:buNone/>
+            </a:pPr>
+            <a:endParaRPr lang="de-DE" sz="2200" b="0" u="none" strike="noStrike">
+              <a:solidFill>
+                <a:srgbClr val="334155"/>
+              </a:solidFill>
+              <a:effectLst/>
+              <a:uFillTx/>
+              <a:latin typeface="Calibri"/>
+            </a:endParaRPr>
+          </a:p>
+        </p:txBody>
+      </p:sp>
+    </p:spTree>
+  </p:cSld>
+</p:sldLayout>
+</file>
+
+<file path=ppt/slideLayouts/slideLayout2.xml><?xml version="1.0" encoding="utf-8"?>
+<p:sldLayout xmlns:a="http://schemas.openxmlformats.org/drawingml/2006/main" xmlns:p="http://schemas.openxmlformats.org/presentationml/2006/main" xmlns:r="http://schemas.openxmlformats.org/officeDocument/2006/relationships" xmlns:p14="http://schemas.microsoft.com/office/powerpoint/2010/main" xmlns:p15="http://schemas.microsoft.com/office/powerpoint/2012/main" xmlns:mc="http://schemas.openxmlformats.org/markup-compatibility/2006" type="blank" preserve="1">
+  <p:cSld name="Abschnitt">
+    <p:spTree>
+      <p:nvGrpSpPr>
+        <p:cNvPr id="1" name=""/>
+        <p:cNvGrpSpPr/>
+        <p:nvPr/>
+      </p:nvGrpSpPr>
+      <p:grpSpPr>
+        <a:xfrm>
+          <a:off x="0" y="0"/>
+          <a:ext cx="0" cy="0"/>
+          <a:chOff x="0" y="0"/>
+          <a:chExt cx="0" cy="0"/>
+        </a:xfrm>
+      </p:grpSpPr>
+    </p:spTree>
+  </p:cSld>
+</p:sldLayout>
+</file>
+
+<file path=ppt/slideLayouts/slideLayout3.xml><?xml version="1.0" encoding="utf-8"?>
+<p:sldLayout xmlns:a="http://schemas.openxmlformats.org/drawingml/2006/main" xmlns:p="http://schemas.openxmlformats.org/presentationml/2006/main" xmlns:r="http://schemas.openxmlformats.org/officeDocument/2006/relationships" xmlns:p14="http://schemas.microsoft.com/office/powerpoint/2010/main" xmlns:p15="http://schemas.microsoft.com/office/powerpoint/2012/main" xmlns:mc="http://schemas.openxmlformats.org/markup-compatibility/2006" type="blank" preserve="1">
+  <p:cSld name="Inhalt">
+    <p:spTree>
+      <p:nvGrpSpPr>
+        <p:cNvPr id="1" name=""/>
+        <p:cNvGrpSpPr/>
+        <p:nvPr/>
+      </p:nvGrpSpPr>
+      <p:grpSpPr>
+        <a:xfrm>
+          <a:off x="0" y="0"/>
+          <a:ext cx="0" cy="0"/>
+          <a:chOff x="0" y="0"/>
+          <a:chExt cx="0" cy="0"/>
+        </a:xfrm>
+      </p:grpSpPr>
+    </p:spTree>
+  </p:cSld>
+</p:sldLayout>
+</file>
+
+<file path=ppt/slideMasters/slideMaster1.xml><?xml version="1.0" encoding="utf-8"?>
+<p:sldMaster xmlns:a="http://schemas.openxmlformats.org/drawingml/2006/main" xmlns:p="http://schemas.openxmlformats.org/presentationml/2006/main" xmlns:r="http://schemas.openxmlformats.org/officeDocument/2006/relationships" xmlns:p14="http://schemas.microsoft.com/office/powerpoint/2010/main" xmlns:p15="http://schemas.microsoft.com/office/powerpoint/2012/main" xmlns:mc="http://schemas.openxmlformats.org/markup-compatibility/2006">
+  <p:cSld>
     <p:bg>
       <p:bgPr>
         <a:solidFill>
@@ -625,12 +780,16 @@
       </p:sp>
     </p:spTree>
   </p:cSld>
-</p:sldLayout>
+  <p:clrMap bg1="lt1" tx1="dk1" bg2="lt2" tx2="dk2" accent1="accent1" accent2="accent2" accent3="accent3" accent4="accent4" accent5="accent5" accent6="accent6" hlink="hlink" folHlink="folHlink"/>
+  <p:sldLayoutIdLst>
+    <p:sldLayoutId id="2147483649" r:id="rId2"/>
+  </p:sldLayoutIdLst>
+</p:sldMaster>
 </file>
 
-<file path=ppt/slideLayouts/slideLayout2.xml><?xml version="1.0" encoding="utf-8"?>
-<p:sldLayout xmlns:a="http://schemas.openxmlformats.org/drawingml/2006/main" xmlns:p="http://schemas.openxmlformats.org/presentationml/2006/main" xmlns:r="http://schemas.openxmlformats.org/officeDocument/2006/relationships" xmlns:p14="http://schemas.microsoft.com/office/powerpoint/2010/main" xmlns:p15="http://schemas.microsoft.com/office/powerpoint/2012/main" xmlns:mc="http://schemas.openxmlformats.org/markup-compatibility/2006" type="blank" preserve="1">
-  <p:cSld name="Abschnitt">
+<file path=ppt/slideMasters/slideMaster2.xml><?xml version="1.0" encoding="utf-8"?>
+<p:sldMaster xmlns:a="http://schemas.openxmlformats.org/drawingml/2006/main" xmlns:p="http://schemas.openxmlformats.org/presentationml/2006/main" xmlns:r="http://schemas.openxmlformats.org/officeDocument/2006/relationships" xmlns:p14="http://schemas.microsoft.com/office/powerpoint/2010/main" xmlns:p15="http://schemas.microsoft.com/office/powerpoint/2012/main" xmlns:mc="http://schemas.openxmlformats.org/markup-compatibility/2006">
+  <p:cSld>
     <p:bg>
       <p:bgPr>
         <a:solidFill>
@@ -654,7 +813,7 @@
       </p:grpSpPr>
       <p:sp>
         <p:nvSpPr>
-          <p:cNvPr id="6" name=""/>
+          <p:cNvPr id="8" name=""/>
           <p:cNvSpPr/>
           <p:nvPr/>
         </p:nvSpPr>
@@ -691,7 +850,7 @@
       </p:sp>
       <p:sp>
         <p:nvSpPr>
-          <p:cNvPr id="7" name=""/>
+          <p:cNvPr id="9" name=""/>
           <p:cNvSpPr txBox="1"/>
           <p:nvPr/>
         </p:nvSpPr>
@@ -738,7 +897,7 @@
       </p:sp>
       <p:sp>
         <p:nvSpPr>
-          <p:cNvPr id="8" name="PlaceHolder 1"/>
+          <p:cNvPr id="10" name="PlaceHolder 1"/>
           <p:cNvSpPr>
             <a:spLocks noGrp="1"/>
           </p:cNvSpPr>
@@ -804,7 +963,7 @@
       </p:sp>
       <p:sp>
         <p:nvSpPr>
-          <p:cNvPr id="9" name="PlaceHolder 2"/>
+          <p:cNvPr id="11" name="PlaceHolder 2"/>
           <p:cNvSpPr>
             <a:spLocks noGrp="1"/>
           </p:cNvSpPr>
@@ -1222,12 +1381,16 @@
       </p:sp>
     </p:spTree>
   </p:cSld>
-</p:sldLayout>
+  <p:clrMap bg1="lt1" tx1="dk1" bg2="lt2" tx2="dk2" accent1="accent1" accent2="accent2" accent3="accent3" accent4="accent4" accent5="accent5" accent6="accent6" hlink="hlink" folHlink="folHlink"/>
+  <p:sldLayoutIdLst>
+    <p:sldLayoutId id="2147483651" r:id="rId2"/>
+  </p:sldLayoutIdLst>
+</p:sldMaster>
 </file>
 
-<file path=ppt/slideLayouts/slideLayout3.xml><?xml version="1.0" encoding="utf-8"?>
-<p:sldLayout xmlns:a="http://schemas.openxmlformats.org/drawingml/2006/main" xmlns:p="http://schemas.openxmlformats.org/presentationml/2006/main" xmlns:r="http://schemas.openxmlformats.org/officeDocument/2006/relationships" xmlns:p14="http://schemas.microsoft.com/office/powerpoint/2010/main" xmlns:p15="http://schemas.microsoft.com/office/powerpoint/2012/main" xmlns:mc="http://schemas.openxmlformats.org/markup-compatibility/2006" type="blank" preserve="1">
-  <p:cSld name="Inhalt">
+<file path=ppt/slideMasters/slideMaster3.xml><?xml version="1.0" encoding="utf-8"?>
+<p:sldMaster xmlns:a="http://schemas.openxmlformats.org/drawingml/2006/main" xmlns:p="http://schemas.openxmlformats.org/presentationml/2006/main" xmlns:r="http://schemas.openxmlformats.org/officeDocument/2006/relationships" xmlns:p14="http://schemas.microsoft.com/office/powerpoint/2010/main" xmlns:p15="http://schemas.microsoft.com/office/powerpoint/2012/main" xmlns:mc="http://schemas.openxmlformats.org/markup-compatibility/2006">
+  <p:cSld>
     <p:bg>
       <p:bgPr>
         <a:solidFill>
@@ -1251,7 +1414,7 @@
       </p:grpSpPr>
       <p:sp>
         <p:nvSpPr>
-          <p:cNvPr id="10" name=""/>
+          <p:cNvPr id="12" name=""/>
           <p:cNvSpPr/>
           <p:nvPr/>
         </p:nvSpPr>
@@ -1288,7 +1451,7 @@
       </p:sp>
       <p:sp>
         <p:nvSpPr>
-          <p:cNvPr id="11" name=""/>
+          <p:cNvPr id="13" name=""/>
           <p:cNvSpPr/>
           <p:nvPr/>
         </p:nvSpPr>
@@ -1325,7 +1488,7 @@
       </p:sp>
       <p:sp>
         <p:nvSpPr>
-          <p:cNvPr id="12" name=""/>
+          <p:cNvPr id="14" name=""/>
           <p:cNvSpPr txBox="1"/>
           <p:nvPr/>
         </p:nvSpPr>
@@ -1372,7 +1535,7 @@
       </p:sp>
       <p:sp>
         <p:nvSpPr>
-          <p:cNvPr id="13" name=""/>
+          <p:cNvPr id="15" name=""/>
           <p:cNvSpPr txBox="1"/>
           <p:nvPr/>
         </p:nvSpPr>
@@ -1395,7 +1558,7 @@
           </a:bodyPr>
           <a:p>
             <a:pPr algn="r"/>
-            <a:fld id="{38CB7028-42E6-473E-A211-05E4CB089E66}" type="slidenum">
+            <a:fld id="{D69022CC-BB42-4435-BBF9-64126298557A}" type="slidenum">
               <a:rPr lang="de-DE" sz="1000" b="0" u="none" strike="noStrike">
                 <a:solidFill>
                   <a:srgbClr val="94A3B8"/>
@@ -1419,7 +1582,7 @@
       </p:sp>
       <p:sp>
         <p:nvSpPr>
-          <p:cNvPr id="14" name="PlaceHolder 1"/>
+          <p:cNvPr id="16" name="PlaceHolder 1"/>
           <p:cNvSpPr>
             <a:spLocks noGrp="1"/>
           </p:cNvSpPr>
@@ -1485,7 +1648,7 @@
       </p:sp>
       <p:sp>
         <p:nvSpPr>
-          <p:cNvPr id="15" name="PlaceHolder 2"/>
+          <p:cNvPr id="17" name="PlaceHolder 2"/>
           <p:cNvSpPr>
             <a:spLocks noGrp="1"/>
           </p:cNvSpPr>
@@ -1903,33 +2066,9 @@
       </p:sp>
     </p:spTree>
   </p:cSld>
-</p:sldLayout>
-</file>
-
-<file path=ppt/slideMasters/slideMaster1.xml><?xml version="1.0" encoding="utf-8"?>
-<p:sldMaster xmlns:a="http://schemas.openxmlformats.org/drawingml/2006/main" xmlns:p="http://schemas.openxmlformats.org/presentationml/2006/main" xmlns:r="http://schemas.openxmlformats.org/officeDocument/2006/relationships" xmlns:p14="http://schemas.microsoft.com/office/powerpoint/2010/main" xmlns:p15="http://schemas.microsoft.com/office/powerpoint/2012/main" xmlns:mc="http://schemas.openxmlformats.org/markup-compatibility/2006">
-  <p:cSld>
-    <p:spTree>
-      <p:nvGrpSpPr>
-        <p:cNvPr id="1" name=""/>
-        <p:cNvGrpSpPr/>
-        <p:nvPr/>
-      </p:nvGrpSpPr>
-      <p:grpSpPr>
-        <a:xfrm>
-          <a:off x="0" y="0"/>
-          <a:ext cx="0" cy="0"/>
-          <a:chOff x="0" y="0"/>
-          <a:chExt cx="0" cy="0"/>
-        </a:xfrm>
-      </p:grpSpPr>
-    </p:spTree>
-  </p:cSld>
   <p:clrMap bg1="lt1" tx1="dk1" bg2="lt2" tx2="dk2" accent1="accent1" accent2="accent2" accent3="accent3" accent4="accent4" accent5="accent5" accent6="accent6" hlink="hlink" folHlink="folHlink"/>
   <p:sldLayoutIdLst>
-    <p:sldLayoutId id="2147483649" r:id="rId2"/>
-    <p:sldLayoutId id="2147483650" r:id="rId3"/>
-    <p:sldLayoutId id="2147483651" r:id="rId4"/>
+    <p:sldLayoutId id="2147483653" r:id="rId2"/>
   </p:sldLayoutIdLst>
 </p:sldMaster>
 </file>
@@ -1953,7 +2092,7 @@
       </p:grpSpPr>
       <p:sp>
         <p:nvSpPr>
-          <p:cNvPr id="16" name="PlaceHolder 1"/>
+          <p:cNvPr id="18" name="PlaceHolder 1"/>
           <p:cNvSpPr>
             <a:spLocks noGrp="1"/>
           </p:cNvSpPr>
@@ -2006,7 +2145,7 @@
       </p:sp>
       <p:sp>
         <p:nvSpPr>
-          <p:cNvPr id="17" name="PlaceHolder 2"/>
+          <p:cNvPr id="19" name="PlaceHolder 2"/>
           <p:cNvSpPr>
             <a:spLocks noGrp="1"/>
           </p:cNvSpPr>
@@ -2119,7 +2258,7 @@
       </p:grpSpPr>
       <p:sp>
         <p:nvSpPr>
-          <p:cNvPr id="75" name=""/>
+          <p:cNvPr id="77" name=""/>
           <p:cNvSpPr txBox="1"/>
           <p:nvPr/>
         </p:nvSpPr>
@@ -2170,7 +2309,7 @@
       </p:sp>
       <p:sp>
         <p:nvSpPr>
-          <p:cNvPr id="76" name="PlaceHolder 1"/>
+          <p:cNvPr id="78" name="PlaceHolder 1"/>
           <p:cNvSpPr>
             <a:spLocks noGrp="1"/>
           </p:cNvSpPr>
@@ -2223,7 +2362,7 @@
       </p:sp>
       <p:sp>
         <p:nvSpPr>
-          <p:cNvPr id="77" name="PlaceHolder 2"/>
+          <p:cNvPr id="79" name="PlaceHolder 2"/>
           <p:cNvSpPr>
             <a:spLocks noGrp="1"/>
           </p:cNvSpPr>
@@ -2309,7 +2448,7 @@
       </p:grpSpPr>
       <p:sp>
         <p:nvSpPr>
-          <p:cNvPr id="78" name="PlaceHolder 1"/>
+          <p:cNvPr id="80" name="PlaceHolder 1"/>
           <p:cNvSpPr>
             <a:spLocks noGrp="1"/>
           </p:cNvSpPr>
@@ -2362,7 +2501,7 @@
       </p:sp>
       <p:sp>
         <p:nvSpPr>
-          <p:cNvPr id="79" name="PlaceHolder 2"/>
+          <p:cNvPr id="81" name="PlaceHolder 2"/>
           <p:cNvSpPr>
             <a:spLocks noGrp="1"/>
           </p:cNvSpPr>
@@ -2673,7 +2812,7 @@
       </p:grpSpPr>
       <p:sp>
         <p:nvSpPr>
-          <p:cNvPr id="80" name="PlaceHolder 1"/>
+          <p:cNvPr id="82" name="PlaceHolder 1"/>
           <p:cNvSpPr>
             <a:spLocks noGrp="1"/>
           </p:cNvSpPr>
@@ -2726,7 +2865,7 @@
       </p:sp>
       <p:sp>
         <p:nvSpPr>
-          <p:cNvPr id="81" name=""/>
+          <p:cNvPr id="83" name=""/>
           <p:cNvSpPr/>
           <p:nvPr/>
         </p:nvSpPr>
@@ -2763,7 +2902,7 @@
       </p:sp>
       <p:sp>
         <p:nvSpPr>
-          <p:cNvPr id="82" name=""/>
+          <p:cNvPr id="84" name=""/>
           <p:cNvSpPr/>
           <p:nvPr/>
         </p:nvSpPr>
@@ -2812,7 +2951,7 @@
       </p:sp>
       <p:sp>
         <p:nvSpPr>
-          <p:cNvPr id="83" name=""/>
+          <p:cNvPr id="85" name=""/>
           <p:cNvSpPr txBox="1"/>
           <p:nvPr/>
         </p:nvSpPr>
@@ -2859,7 +2998,7 @@
       </p:sp>
       <p:sp>
         <p:nvSpPr>
-          <p:cNvPr id="84" name=""/>
+          <p:cNvPr id="86" name=""/>
           <p:cNvSpPr txBox="1"/>
           <p:nvPr/>
         </p:nvSpPr>
@@ -2910,7 +3049,7 @@
       </p:sp>
       <p:sp>
         <p:nvSpPr>
-          <p:cNvPr id="85" name=""/>
+          <p:cNvPr id="87" name=""/>
           <p:cNvSpPr/>
           <p:nvPr/>
         </p:nvSpPr>
@@ -2959,7 +3098,7 @@
       </p:sp>
       <p:sp>
         <p:nvSpPr>
-          <p:cNvPr id="86" name=""/>
+          <p:cNvPr id="88" name=""/>
           <p:cNvSpPr txBox="1"/>
           <p:nvPr/>
         </p:nvSpPr>
@@ -3006,7 +3145,7 @@
       </p:sp>
       <p:sp>
         <p:nvSpPr>
-          <p:cNvPr id="87" name=""/>
+          <p:cNvPr id="89" name=""/>
           <p:cNvSpPr txBox="1"/>
           <p:nvPr/>
         </p:nvSpPr>
@@ -3057,7 +3196,7 @@
       </p:sp>
       <p:sp>
         <p:nvSpPr>
-          <p:cNvPr id="88" name=""/>
+          <p:cNvPr id="90" name=""/>
           <p:cNvSpPr/>
           <p:nvPr/>
         </p:nvSpPr>
@@ -3106,7 +3245,7 @@
       </p:sp>
       <p:sp>
         <p:nvSpPr>
-          <p:cNvPr id="89" name=""/>
+          <p:cNvPr id="91" name=""/>
           <p:cNvSpPr txBox="1"/>
           <p:nvPr/>
         </p:nvSpPr>
@@ -3153,7 +3292,7 @@
       </p:sp>
       <p:sp>
         <p:nvSpPr>
-          <p:cNvPr id="90" name=""/>
+          <p:cNvPr id="92" name=""/>
           <p:cNvSpPr txBox="1"/>
           <p:nvPr/>
         </p:nvSpPr>
@@ -3204,7 +3343,7 @@
       </p:sp>
       <p:sp>
         <p:nvSpPr>
-          <p:cNvPr id="91" name=""/>
+          <p:cNvPr id="93" name=""/>
           <p:cNvSpPr/>
           <p:nvPr/>
         </p:nvSpPr>
@@ -3253,7 +3392,7 @@
       </p:sp>
       <p:sp>
         <p:nvSpPr>
-          <p:cNvPr id="92" name=""/>
+          <p:cNvPr id="94" name=""/>
           <p:cNvSpPr txBox="1"/>
           <p:nvPr/>
         </p:nvSpPr>
@@ -3300,7 +3439,7 @@
       </p:sp>
       <p:sp>
         <p:nvSpPr>
-          <p:cNvPr id="93" name=""/>
+          <p:cNvPr id="95" name=""/>
           <p:cNvSpPr txBox="1"/>
           <p:nvPr/>
         </p:nvSpPr>
@@ -3351,7 +3490,7 @@
       </p:sp>
       <p:sp>
         <p:nvSpPr>
-          <p:cNvPr id="94" name=""/>
+          <p:cNvPr id="96" name=""/>
           <p:cNvSpPr txBox="1"/>
           <p:nvPr/>
         </p:nvSpPr>
@@ -3432,7 +3571,7 @@
       </p:grpSpPr>
       <p:sp>
         <p:nvSpPr>
-          <p:cNvPr id="95" name="PlaceHolder 1"/>
+          <p:cNvPr id="97" name="PlaceHolder 1"/>
           <p:cNvSpPr>
             <a:spLocks noGrp="1"/>
           </p:cNvSpPr>
@@ -3485,7 +3624,7 @@
       </p:sp>
       <p:sp>
         <p:nvSpPr>
-          <p:cNvPr id="96" name=""/>
+          <p:cNvPr id="98" name=""/>
           <p:cNvSpPr/>
           <p:nvPr/>
         </p:nvSpPr>
@@ -3522,7 +3661,7 @@
       </p:sp>
       <p:sp>
         <p:nvSpPr>
-          <p:cNvPr id="97" name=""/>
+          <p:cNvPr id="99" name=""/>
           <p:cNvSpPr/>
           <p:nvPr/>
         </p:nvSpPr>
@@ -3559,7 +3698,7 @@
       </p:sp>
       <p:sp>
         <p:nvSpPr>
-          <p:cNvPr id="98" name=""/>
+          <p:cNvPr id="100" name=""/>
           <p:cNvSpPr txBox="1"/>
           <p:nvPr/>
         </p:nvSpPr>
@@ -3610,7 +3749,7 @@
       </p:sp>
       <p:sp>
         <p:nvSpPr>
-          <p:cNvPr id="99" name=""/>
+          <p:cNvPr id="101" name=""/>
           <p:cNvSpPr txBox="1"/>
           <p:nvPr/>
         </p:nvSpPr>
@@ -3693,7 +3832,7 @@
       </p:sp>
       <p:sp>
         <p:nvSpPr>
-          <p:cNvPr id="100" name=""/>
+          <p:cNvPr id="102" name=""/>
           <p:cNvSpPr/>
           <p:nvPr/>
         </p:nvSpPr>
@@ -3730,7 +3869,7 @@
       </p:sp>
       <p:sp>
         <p:nvSpPr>
-          <p:cNvPr id="101" name=""/>
+          <p:cNvPr id="103" name=""/>
           <p:cNvSpPr/>
           <p:nvPr/>
         </p:nvSpPr>
@@ -3767,7 +3906,7 @@
       </p:sp>
       <p:sp>
         <p:nvSpPr>
-          <p:cNvPr id="102" name=""/>
+          <p:cNvPr id="104" name=""/>
           <p:cNvSpPr txBox="1"/>
           <p:nvPr/>
         </p:nvSpPr>
@@ -3818,7 +3957,7 @@
       </p:sp>
       <p:sp>
         <p:nvSpPr>
-          <p:cNvPr id="103" name=""/>
+          <p:cNvPr id="105" name=""/>
           <p:cNvSpPr txBox="1"/>
           <p:nvPr/>
         </p:nvSpPr>
@@ -3901,7 +4040,7 @@
       </p:sp>
       <p:sp>
         <p:nvSpPr>
-          <p:cNvPr id="104" name=""/>
+          <p:cNvPr id="106" name=""/>
           <p:cNvSpPr/>
           <p:nvPr/>
         </p:nvSpPr>
@@ -3938,7 +4077,7 @@
       </p:sp>
       <p:sp>
         <p:nvSpPr>
-          <p:cNvPr id="105" name=""/>
+          <p:cNvPr id="107" name=""/>
           <p:cNvSpPr/>
           <p:nvPr/>
         </p:nvSpPr>
@@ -3975,7 +4114,7 @@
       </p:sp>
       <p:sp>
         <p:nvSpPr>
-          <p:cNvPr id="106" name=""/>
+          <p:cNvPr id="108" name=""/>
           <p:cNvSpPr txBox="1"/>
           <p:nvPr/>
         </p:nvSpPr>
@@ -4026,7 +4165,7 @@
       </p:sp>
       <p:sp>
         <p:nvSpPr>
-          <p:cNvPr id="107" name=""/>
+          <p:cNvPr id="109" name=""/>
           <p:cNvSpPr txBox="1"/>
           <p:nvPr/>
         </p:nvSpPr>
@@ -4109,7 +4248,7 @@
       </p:sp>
       <p:sp>
         <p:nvSpPr>
-          <p:cNvPr id="108" name=""/>
+          <p:cNvPr id="110" name=""/>
           <p:cNvSpPr/>
           <p:nvPr/>
         </p:nvSpPr>
@@ -4146,7 +4285,7 @@
       </p:sp>
       <p:sp>
         <p:nvSpPr>
-          <p:cNvPr id="109" name=""/>
+          <p:cNvPr id="111" name=""/>
           <p:cNvSpPr/>
           <p:nvPr/>
         </p:nvSpPr>
@@ -4183,7 +4322,7 @@
       </p:sp>
       <p:sp>
         <p:nvSpPr>
-          <p:cNvPr id="110" name=""/>
+          <p:cNvPr id="112" name=""/>
           <p:cNvSpPr txBox="1"/>
           <p:nvPr/>
         </p:nvSpPr>
@@ -4234,7 +4373,7 @@
       </p:sp>
       <p:sp>
         <p:nvSpPr>
-          <p:cNvPr id="111" name=""/>
+          <p:cNvPr id="113" name=""/>
           <p:cNvSpPr txBox="1"/>
           <p:nvPr/>
         </p:nvSpPr>
@@ -4317,7 +4456,7 @@
       </p:sp>
       <p:sp>
         <p:nvSpPr>
-          <p:cNvPr id="112" name=""/>
+          <p:cNvPr id="114" name=""/>
           <p:cNvSpPr txBox="1"/>
           <p:nvPr/>
         </p:nvSpPr>
@@ -4398,7 +4537,7 @@
       </p:grpSpPr>
       <p:sp>
         <p:nvSpPr>
-          <p:cNvPr id="113" name=""/>
+          <p:cNvPr id="115" name=""/>
           <p:cNvSpPr txBox="1"/>
           <p:nvPr/>
         </p:nvSpPr>
@@ -4449,7 +4588,7 @@
       </p:sp>
       <p:sp>
         <p:nvSpPr>
-          <p:cNvPr id="114" name="PlaceHolder 1"/>
+          <p:cNvPr id="116" name="PlaceHolder 1"/>
           <p:cNvSpPr>
             <a:spLocks noGrp="1"/>
           </p:cNvSpPr>
@@ -4502,7 +4641,7 @@
       </p:sp>
       <p:sp>
         <p:nvSpPr>
-          <p:cNvPr id="115" name="PlaceHolder 2"/>
+          <p:cNvPr id="117" name="PlaceHolder 2"/>
           <p:cNvSpPr>
             <a:spLocks noGrp="1"/>
           </p:cNvSpPr>
@@ -4588,7 +4727,7 @@
       </p:grpSpPr>
       <p:sp>
         <p:nvSpPr>
-          <p:cNvPr id="116" name="PlaceHolder 1"/>
+          <p:cNvPr id="118" name="PlaceHolder 1"/>
           <p:cNvSpPr>
             <a:spLocks noGrp="1"/>
           </p:cNvSpPr>
@@ -4641,7 +4780,7 @@
       </p:sp>
       <p:sp>
         <p:nvSpPr>
-          <p:cNvPr id="117" name=""/>
+          <p:cNvPr id="119" name=""/>
           <p:cNvSpPr/>
           <p:nvPr/>
         </p:nvSpPr>
@@ -4678,7 +4817,7 @@
       </p:sp>
       <p:sp>
         <p:nvSpPr>
-          <p:cNvPr id="118" name=""/>
+          <p:cNvPr id="120" name=""/>
           <p:cNvSpPr/>
           <p:nvPr/>
         </p:nvSpPr>
@@ -4715,7 +4854,7 @@
       </p:sp>
       <p:sp>
         <p:nvSpPr>
-          <p:cNvPr id="119" name=""/>
+          <p:cNvPr id="121" name=""/>
           <p:cNvSpPr txBox="1"/>
           <p:nvPr/>
         </p:nvSpPr>
@@ -4766,7 +4905,7 @@
       </p:sp>
       <p:sp>
         <p:nvSpPr>
-          <p:cNvPr id="120" name=""/>
+          <p:cNvPr id="122" name=""/>
           <p:cNvSpPr txBox="1"/>
           <p:nvPr/>
         </p:nvSpPr>
@@ -4878,7 +5017,7 @@
       </p:sp>
       <p:sp>
         <p:nvSpPr>
-          <p:cNvPr id="121" name=""/>
+          <p:cNvPr id="123" name=""/>
           <p:cNvSpPr/>
           <p:nvPr/>
         </p:nvSpPr>
@@ -4915,7 +5054,7 @@
       </p:sp>
       <p:sp>
         <p:nvSpPr>
-          <p:cNvPr id="122" name=""/>
+          <p:cNvPr id="124" name=""/>
           <p:cNvSpPr/>
           <p:nvPr/>
         </p:nvSpPr>
@@ -4952,7 +5091,7 @@
       </p:sp>
       <p:sp>
         <p:nvSpPr>
-          <p:cNvPr id="123" name=""/>
+          <p:cNvPr id="125" name=""/>
           <p:cNvSpPr txBox="1"/>
           <p:nvPr/>
         </p:nvSpPr>
@@ -5003,7 +5142,7 @@
       </p:sp>
       <p:sp>
         <p:nvSpPr>
-          <p:cNvPr id="124" name=""/>
+          <p:cNvPr id="126" name=""/>
           <p:cNvSpPr txBox="1"/>
           <p:nvPr/>
         </p:nvSpPr>
@@ -5115,7 +5254,7 @@
       </p:sp>
       <p:sp>
         <p:nvSpPr>
-          <p:cNvPr id="125" name=""/>
+          <p:cNvPr id="127" name=""/>
           <p:cNvSpPr txBox="1"/>
           <p:nvPr/>
         </p:nvSpPr>
@@ -5151,7 +5290,7 @@
                 <a:uFillTx/>
                 <a:latin typeface="Calibri"/>
               </a:rPr>
-              <a:t>Anbieten: 👥 auf der Themenkarte oder in den Notebooks über ⋯ → Teilen.</a:t>
+              <a:t>Anbieten: 👥 auf der Themenkarte oder in den Notebooks über … → Teilen – mit Fach und Stufe.</a:t>
             </a:r>
             <a:endParaRPr lang="de-DE" sz="1600" b="0" u="none" strike="noStrike">
               <a:solidFill>
@@ -5196,7 +5335,7 @@
       </p:grpSpPr>
       <p:sp>
         <p:nvSpPr>
-          <p:cNvPr id="126" name="PlaceHolder 1"/>
+          <p:cNvPr id="128" name="PlaceHolder 1"/>
           <p:cNvSpPr>
             <a:spLocks noGrp="1"/>
           </p:cNvSpPr>
@@ -5249,7 +5388,7 @@
       </p:sp>
       <p:sp>
         <p:nvSpPr>
-          <p:cNvPr id="127" name="PlaceHolder 2"/>
+          <p:cNvPr id="129" name="PlaceHolder 2"/>
           <p:cNvSpPr>
             <a:spLocks noGrp="1"/>
           </p:cNvSpPr>
@@ -5504,7 +5643,7 @@
                 <a:uFillTx/>
                 <a:latin typeface="Calibri"/>
               </a:rPr>
-              <a:t>🌐 Verbundene Server</a:t>
+              <a:t>🌐 Andere Schulen</a:t>
             </a:r>
             <a:r>
               <a:rPr lang="de-DE" sz="2400" b="0" u="none" strike="noStrike">
@@ -5515,7 +5654,7 @@
                 <a:uFillTx/>
                 <a:latin typeface="Calibri"/>
               </a:rPr>
-              <a:t> – Angebote anderer Schulen im Shop</a:t>
+              <a:t> – verbunden oder im 🕸 Vertrauensnetzwerk</a:t>
             </a:r>
             <a:endParaRPr lang="de-DE" sz="2400" b="0" u="none" strike="noStrike">
               <a:solidFill>
@@ -5560,7 +5699,7 @@
       </p:grpSpPr>
       <p:sp>
         <p:nvSpPr>
-          <p:cNvPr id="128" name="PlaceHolder 1"/>
+          <p:cNvPr id="130" name="PlaceHolder 1"/>
           <p:cNvSpPr>
             <a:spLocks noGrp="1"/>
           </p:cNvSpPr>
@@ -5613,7 +5752,7 @@
       </p:sp>
       <p:sp>
         <p:nvSpPr>
-          <p:cNvPr id="129" name="PlaceHolder 2"/>
+          <p:cNvPr id="131" name="PlaceHolder 2"/>
           <p:cNvSpPr>
             <a:spLocks noGrp="1"/>
           </p:cNvSpPr>
@@ -5856,7 +5995,7 @@
       </p:grpSpPr>
       <p:sp>
         <p:nvSpPr>
-          <p:cNvPr id="130" name=""/>
+          <p:cNvPr id="132" name=""/>
           <p:cNvSpPr txBox="1"/>
           <p:nvPr/>
         </p:nvSpPr>
@@ -5907,7 +6046,7 @@
       </p:sp>
       <p:sp>
         <p:nvSpPr>
-          <p:cNvPr id="131" name="PlaceHolder 1"/>
+          <p:cNvPr id="133" name="PlaceHolder 1"/>
           <p:cNvSpPr>
             <a:spLocks noGrp="1"/>
           </p:cNvSpPr>
@@ -5960,7 +6099,7 @@
       </p:sp>
       <p:sp>
         <p:nvSpPr>
-          <p:cNvPr id="132" name="PlaceHolder 2"/>
+          <p:cNvPr id="134" name="PlaceHolder 2"/>
           <p:cNvSpPr>
             <a:spLocks noGrp="1"/>
           </p:cNvSpPr>
@@ -6046,7 +6185,7 @@
       </p:grpSpPr>
       <p:sp>
         <p:nvSpPr>
-          <p:cNvPr id="133" name="PlaceHolder 1"/>
+          <p:cNvPr id="135" name="PlaceHolder 1"/>
           <p:cNvSpPr>
             <a:spLocks noGrp="1"/>
           </p:cNvSpPr>
@@ -6099,7 +6238,7 @@
       </p:sp>
       <p:sp>
         <p:nvSpPr>
-          <p:cNvPr id="134" name=""/>
+          <p:cNvPr id="136" name=""/>
           <p:cNvSpPr/>
           <p:nvPr/>
         </p:nvSpPr>
@@ -6136,7 +6275,7 @@
       </p:sp>
       <p:sp>
         <p:nvSpPr>
-          <p:cNvPr id="135" name=""/>
+          <p:cNvPr id="137" name=""/>
           <p:cNvSpPr/>
           <p:nvPr/>
         </p:nvSpPr>
@@ -6185,7 +6324,7 @@
       </p:sp>
       <p:sp>
         <p:nvSpPr>
-          <p:cNvPr id="136" name=""/>
+          <p:cNvPr id="138" name=""/>
           <p:cNvSpPr txBox="1"/>
           <p:nvPr/>
         </p:nvSpPr>
@@ -6232,7 +6371,7 @@
       </p:sp>
       <p:sp>
         <p:nvSpPr>
-          <p:cNvPr id="137" name=""/>
+          <p:cNvPr id="139" name=""/>
           <p:cNvSpPr txBox="1"/>
           <p:nvPr/>
         </p:nvSpPr>
@@ -6268,7 +6407,7 @@
                 <a:uFillTx/>
                 <a:latin typeface="Calibri"/>
               </a:rPr>
-              <a:t>Lernthema mit Fach und Stufe</a:t>
+              <a:t>Lernthema mit Titel und Tags</a:t>
             </a:r>
             <a:endParaRPr lang="de-DE" sz="1700" b="0" u="none" strike="noStrike">
               <a:solidFill>
@@ -6283,7 +6422,7 @@
       </p:sp>
       <p:sp>
         <p:nvSpPr>
-          <p:cNvPr id="138" name=""/>
+          <p:cNvPr id="140" name=""/>
           <p:cNvSpPr/>
           <p:nvPr/>
         </p:nvSpPr>
@@ -6332,7 +6471,7 @@
       </p:sp>
       <p:sp>
         <p:nvSpPr>
-          <p:cNvPr id="139" name=""/>
+          <p:cNvPr id="141" name=""/>
           <p:cNvSpPr txBox="1"/>
           <p:nvPr/>
         </p:nvSpPr>
@@ -6379,7 +6518,7 @@
       </p:sp>
       <p:sp>
         <p:nvSpPr>
-          <p:cNvPr id="140" name=""/>
+          <p:cNvPr id="142" name=""/>
           <p:cNvSpPr txBox="1"/>
           <p:nvPr/>
         </p:nvSpPr>
@@ -6430,7 +6569,7 @@
       </p:sp>
       <p:sp>
         <p:nvSpPr>
-          <p:cNvPr id="141" name=""/>
+          <p:cNvPr id="143" name=""/>
           <p:cNvSpPr/>
           <p:nvPr/>
         </p:nvSpPr>
@@ -6479,7 +6618,7 @@
       </p:sp>
       <p:sp>
         <p:nvSpPr>
-          <p:cNvPr id="142" name=""/>
+          <p:cNvPr id="144" name=""/>
           <p:cNvSpPr txBox="1"/>
           <p:nvPr/>
         </p:nvSpPr>
@@ -6526,7 +6665,7 @@
       </p:sp>
       <p:sp>
         <p:nvSpPr>
-          <p:cNvPr id="143" name=""/>
+          <p:cNvPr id="145" name=""/>
           <p:cNvSpPr txBox="1"/>
           <p:nvPr/>
         </p:nvSpPr>
@@ -6577,7 +6716,7 @@
       </p:sp>
       <p:sp>
         <p:nvSpPr>
-          <p:cNvPr id="144" name=""/>
+          <p:cNvPr id="146" name=""/>
           <p:cNvSpPr/>
           <p:nvPr/>
         </p:nvSpPr>
@@ -6626,7 +6765,7 @@
       </p:sp>
       <p:sp>
         <p:nvSpPr>
-          <p:cNvPr id="145" name=""/>
+          <p:cNvPr id="147" name=""/>
           <p:cNvSpPr txBox="1"/>
           <p:nvPr/>
         </p:nvSpPr>
@@ -6673,7 +6812,7 @@
       </p:sp>
       <p:sp>
         <p:nvSpPr>
-          <p:cNvPr id="146" name=""/>
+          <p:cNvPr id="148" name=""/>
           <p:cNvSpPr txBox="1"/>
           <p:nvPr/>
         </p:nvSpPr>
@@ -6724,7 +6863,7 @@
       </p:sp>
       <p:sp>
         <p:nvSpPr>
-          <p:cNvPr id="147" name=""/>
+          <p:cNvPr id="149" name=""/>
           <p:cNvSpPr/>
           <p:nvPr/>
         </p:nvSpPr>
@@ -6773,7 +6912,7 @@
       </p:sp>
       <p:sp>
         <p:nvSpPr>
-          <p:cNvPr id="148" name=""/>
+          <p:cNvPr id="150" name=""/>
           <p:cNvSpPr txBox="1"/>
           <p:nvPr/>
         </p:nvSpPr>
@@ -6820,7 +6959,7 @@
       </p:sp>
       <p:sp>
         <p:nvSpPr>
-          <p:cNvPr id="149" name=""/>
+          <p:cNvPr id="151" name=""/>
           <p:cNvSpPr txBox="1"/>
           <p:nvPr/>
         </p:nvSpPr>
@@ -6901,7 +7040,7 @@
       </p:grpSpPr>
       <p:sp>
         <p:nvSpPr>
-          <p:cNvPr id="18" name="PlaceHolder 1"/>
+          <p:cNvPr id="20" name="PlaceHolder 1"/>
           <p:cNvSpPr>
             <a:spLocks noGrp="1"/>
           </p:cNvSpPr>
@@ -6954,7 +7093,7 @@
       </p:sp>
       <p:sp>
         <p:nvSpPr>
-          <p:cNvPr id="19" name=""/>
+          <p:cNvPr id="21" name=""/>
           <p:cNvSpPr txBox="1"/>
           <p:nvPr/>
         </p:nvSpPr>
@@ -7119,7 +7258,7 @@
       </p:sp>
       <p:sp>
         <p:nvSpPr>
-          <p:cNvPr id="20" name=""/>
+          <p:cNvPr id="22" name=""/>
           <p:cNvSpPr txBox="1"/>
           <p:nvPr/>
         </p:nvSpPr>
@@ -7314,7 +7453,7 @@
       </p:grpSpPr>
       <p:sp>
         <p:nvSpPr>
-          <p:cNvPr id="150" name="PlaceHolder 1"/>
+          <p:cNvPr id="152" name="PlaceHolder 1"/>
           <p:cNvSpPr>
             <a:spLocks noGrp="1"/>
           </p:cNvSpPr>
@@ -7367,7 +7506,7 @@
       </p:sp>
       <p:sp>
         <p:nvSpPr>
-          <p:cNvPr id="151" name="PlaceHolder 2"/>
+          <p:cNvPr id="153" name="PlaceHolder 2"/>
           <p:cNvSpPr>
             <a:spLocks noGrp="1"/>
           </p:cNvSpPr>
@@ -7610,7 +7749,7 @@
       </p:grpSpPr>
       <p:sp>
         <p:nvSpPr>
-          <p:cNvPr id="21" name="PlaceHolder 1"/>
+          <p:cNvPr id="23" name="PlaceHolder 1"/>
           <p:cNvSpPr>
             <a:spLocks noGrp="1"/>
           </p:cNvSpPr>
@@ -7663,7 +7802,7 @@
       </p:sp>
       <p:sp>
         <p:nvSpPr>
-          <p:cNvPr id="22" name=""/>
+          <p:cNvPr id="24" name=""/>
           <p:cNvSpPr txBox="1"/>
           <p:nvPr/>
         </p:nvSpPr>
@@ -7816,7 +7955,7 @@
       </p:sp>
       <p:sp>
         <p:nvSpPr>
-          <p:cNvPr id="23" name=""/>
+          <p:cNvPr id="25" name=""/>
           <p:cNvSpPr/>
           <p:nvPr/>
         </p:nvSpPr>
@@ -7859,7 +7998,7 @@
       </p:sp>
       <p:sp>
         <p:nvSpPr>
-          <p:cNvPr id="24" name=""/>
+          <p:cNvPr id="26" name=""/>
           <p:cNvSpPr/>
           <p:nvPr/>
         </p:nvSpPr>
@@ -7902,7 +8041,7 @@
       </p:sp>
       <p:sp>
         <p:nvSpPr>
-          <p:cNvPr id="25" name=""/>
+          <p:cNvPr id="27" name=""/>
           <p:cNvSpPr/>
           <p:nvPr/>
         </p:nvSpPr>
@@ -7945,7 +8084,7 @@
       </p:sp>
       <p:sp>
         <p:nvSpPr>
-          <p:cNvPr id="26" name=""/>
+          <p:cNvPr id="28" name=""/>
           <p:cNvSpPr/>
           <p:nvPr/>
         </p:nvSpPr>
@@ -7988,7 +8127,7 @@
       </p:sp>
       <p:sp>
         <p:nvSpPr>
-          <p:cNvPr id="27" name=""/>
+          <p:cNvPr id="29" name=""/>
           <p:cNvSpPr/>
           <p:nvPr/>
         </p:nvSpPr>
@@ -8031,7 +8170,7 @@
       </p:sp>
       <p:sp>
         <p:nvSpPr>
-          <p:cNvPr id="28" name=""/>
+          <p:cNvPr id="30" name=""/>
           <p:cNvSpPr/>
           <p:nvPr/>
         </p:nvSpPr>
@@ -8074,7 +8213,7 @@
       </p:sp>
       <p:sp>
         <p:nvSpPr>
-          <p:cNvPr id="29" name=""/>
+          <p:cNvPr id="31" name=""/>
           <p:cNvSpPr/>
           <p:nvPr/>
         </p:nvSpPr>
@@ -8117,7 +8256,7 @@
       </p:sp>
       <p:sp>
         <p:nvSpPr>
-          <p:cNvPr id="30" name=""/>
+          <p:cNvPr id="32" name=""/>
           <p:cNvSpPr/>
           <p:nvPr/>
         </p:nvSpPr>
@@ -8160,7 +8299,7 @@
       </p:sp>
       <p:sp>
         <p:nvSpPr>
-          <p:cNvPr id="31" name=""/>
+          <p:cNvPr id="33" name=""/>
           <p:cNvSpPr/>
           <p:nvPr/>
         </p:nvSpPr>
@@ -8200,7 +8339,7 @@
       </p:sp>
       <p:sp>
         <p:nvSpPr>
-          <p:cNvPr id="32" name=""/>
+          <p:cNvPr id="34" name=""/>
           <p:cNvSpPr txBox="1"/>
           <p:nvPr/>
         </p:nvSpPr>
@@ -8247,7 +8386,7 @@
       </p:sp>
       <p:pic>
         <p:nvPicPr>
-          <p:cNvPr id="33" name=""/>
+          <p:cNvPr id="35" name=""/>
           <p:cNvPicPr/>
           <p:nvPr/>
         </p:nvPicPr>
@@ -8271,7 +8410,7 @@
       </p:pic>
       <p:sp>
         <p:nvSpPr>
-          <p:cNvPr id="34" name=""/>
+          <p:cNvPr id="36" name=""/>
           <p:cNvSpPr/>
           <p:nvPr/>
         </p:nvSpPr>
@@ -8311,7 +8450,7 @@
       </p:sp>
       <p:sp>
         <p:nvSpPr>
-          <p:cNvPr id="35" name=""/>
+          <p:cNvPr id="37" name=""/>
           <p:cNvSpPr txBox="1"/>
           <p:nvPr/>
         </p:nvSpPr>
@@ -8358,7 +8497,7 @@
       </p:sp>
       <p:pic>
         <p:nvPicPr>
-          <p:cNvPr id="36" name=""/>
+          <p:cNvPr id="38" name=""/>
           <p:cNvPicPr/>
           <p:nvPr/>
         </p:nvPicPr>
@@ -8382,7 +8521,7 @@
       </p:pic>
       <p:sp>
         <p:nvSpPr>
-          <p:cNvPr id="37" name=""/>
+          <p:cNvPr id="39" name=""/>
           <p:cNvSpPr/>
           <p:nvPr/>
         </p:nvSpPr>
@@ -8422,7 +8561,7 @@
       </p:sp>
       <p:sp>
         <p:nvSpPr>
-          <p:cNvPr id="38" name=""/>
+          <p:cNvPr id="40" name=""/>
           <p:cNvSpPr txBox="1"/>
           <p:nvPr/>
         </p:nvSpPr>
@@ -8469,7 +8608,7 @@
       </p:sp>
       <p:pic>
         <p:nvPicPr>
-          <p:cNvPr id="39" name=""/>
+          <p:cNvPr id="41" name=""/>
           <p:cNvPicPr/>
           <p:nvPr/>
         </p:nvPicPr>
@@ -8493,7 +8632,7 @@
       </p:pic>
       <p:sp>
         <p:nvSpPr>
-          <p:cNvPr id="40" name=""/>
+          <p:cNvPr id="42" name=""/>
           <p:cNvSpPr/>
           <p:nvPr/>
         </p:nvSpPr>
@@ -8533,7 +8672,7 @@
       </p:sp>
       <p:sp>
         <p:nvSpPr>
-          <p:cNvPr id="41" name=""/>
+          <p:cNvPr id="43" name=""/>
           <p:cNvSpPr txBox="1"/>
           <p:nvPr/>
         </p:nvSpPr>
@@ -8580,7 +8719,7 @@
       </p:sp>
       <p:pic>
         <p:nvPicPr>
-          <p:cNvPr id="42" name=""/>
+          <p:cNvPr id="44" name=""/>
           <p:cNvPicPr/>
           <p:nvPr/>
         </p:nvPicPr>
@@ -8604,7 +8743,7 @@
       </p:pic>
       <p:sp>
         <p:nvSpPr>
-          <p:cNvPr id="43" name=""/>
+          <p:cNvPr id="45" name=""/>
           <p:cNvSpPr/>
           <p:nvPr/>
         </p:nvSpPr>
@@ -8644,7 +8783,7 @@
       </p:sp>
       <p:sp>
         <p:nvSpPr>
-          <p:cNvPr id="44" name=""/>
+          <p:cNvPr id="46" name=""/>
           <p:cNvSpPr txBox="1"/>
           <p:nvPr/>
         </p:nvSpPr>
@@ -8691,7 +8830,7 @@
       </p:sp>
       <p:pic>
         <p:nvPicPr>
-          <p:cNvPr id="45" name=""/>
+          <p:cNvPr id="47" name=""/>
           <p:cNvPicPr/>
           <p:nvPr/>
         </p:nvPicPr>
@@ -8745,7 +8884,7 @@
       </p:grpSpPr>
       <p:sp>
         <p:nvSpPr>
-          <p:cNvPr id="46" name="PlaceHolder 1"/>
+          <p:cNvPr id="48" name="PlaceHolder 1"/>
           <p:cNvSpPr>
             <a:spLocks noGrp="1"/>
           </p:cNvSpPr>
@@ -8798,7 +8937,7 @@
       </p:sp>
       <p:sp>
         <p:nvSpPr>
-          <p:cNvPr id="47" name=""/>
+          <p:cNvPr id="49" name=""/>
           <p:cNvSpPr/>
           <p:nvPr/>
         </p:nvSpPr>
@@ -8835,7 +8974,7 @@
       </p:sp>
       <p:sp>
         <p:nvSpPr>
-          <p:cNvPr id="48" name=""/>
+          <p:cNvPr id="50" name=""/>
           <p:cNvSpPr/>
           <p:nvPr/>
         </p:nvSpPr>
@@ -8872,7 +9011,7 @@
       </p:sp>
       <p:sp>
         <p:nvSpPr>
-          <p:cNvPr id="49" name=""/>
+          <p:cNvPr id="51" name=""/>
           <p:cNvSpPr txBox="1"/>
           <p:nvPr/>
         </p:nvSpPr>
@@ -8993,7 +9132,7 @@
       </p:sp>
       <p:sp>
         <p:nvSpPr>
-          <p:cNvPr id="50" name=""/>
+          <p:cNvPr id="52" name=""/>
           <p:cNvSpPr txBox="1"/>
           <p:nvPr/>
         </p:nvSpPr>
@@ -9294,7 +9433,7 @@
       </p:sp>
       <p:sp>
         <p:nvSpPr>
-          <p:cNvPr id="51" name=""/>
+          <p:cNvPr id="53" name=""/>
           <p:cNvSpPr txBox="1"/>
           <p:nvPr/>
         </p:nvSpPr>
@@ -9375,7 +9514,7 @@
       </p:grpSpPr>
       <p:sp>
         <p:nvSpPr>
-          <p:cNvPr id="52" name="PlaceHolder 1"/>
+          <p:cNvPr id="54" name="PlaceHolder 1"/>
           <p:cNvSpPr>
             <a:spLocks noGrp="1"/>
           </p:cNvSpPr>
@@ -9428,7 +9567,7 @@
       </p:sp>
       <p:sp>
         <p:nvSpPr>
-          <p:cNvPr id="53" name="PlaceHolder 2"/>
+          <p:cNvPr id="55" name="PlaceHolder 2"/>
           <p:cNvSpPr>
             <a:spLocks noGrp="1"/>
           </p:cNvSpPr>
@@ -9716,7 +9855,7 @@
       </p:grpSpPr>
       <p:sp>
         <p:nvSpPr>
-          <p:cNvPr id="54" name=""/>
+          <p:cNvPr id="56" name=""/>
           <p:cNvSpPr txBox="1"/>
           <p:nvPr/>
         </p:nvSpPr>
@@ -9767,7 +9906,7 @@
       </p:sp>
       <p:sp>
         <p:nvSpPr>
-          <p:cNvPr id="55" name="PlaceHolder 1"/>
+          <p:cNvPr id="57" name="PlaceHolder 1"/>
           <p:cNvSpPr>
             <a:spLocks noGrp="1"/>
           </p:cNvSpPr>
@@ -9820,7 +9959,7 @@
       </p:sp>
       <p:sp>
         <p:nvSpPr>
-          <p:cNvPr id="56" name="PlaceHolder 2"/>
+          <p:cNvPr id="58" name="PlaceHolder 2"/>
           <p:cNvSpPr>
             <a:spLocks noGrp="1"/>
           </p:cNvSpPr>
@@ -9906,7 +10045,7 @@
       </p:grpSpPr>
       <p:sp>
         <p:nvSpPr>
-          <p:cNvPr id="57" name="PlaceHolder 1"/>
+          <p:cNvPr id="59" name="PlaceHolder 1"/>
           <p:cNvSpPr>
             <a:spLocks noGrp="1"/>
           </p:cNvSpPr>
@@ -9959,7 +10098,7 @@
       </p:sp>
       <p:sp>
         <p:nvSpPr>
-          <p:cNvPr id="58" name="PlaceHolder 2"/>
+          <p:cNvPr id="60" name="PlaceHolder 2"/>
           <p:cNvSpPr>
             <a:spLocks noGrp="1"/>
           </p:cNvSpPr>
@@ -10042,7 +10181,7 @@
                 <a:uFillTx/>
                 <a:latin typeface="Calibri"/>
               </a:rPr>
-              <a:t>Titel, Beschreibung, Fach und Stufe</a:t>
+              <a:t>Titel, Beschreibung und Tags</a:t>
             </a:r>
             <a:endParaRPr lang="de-DE" sz="1900" b="0" u="none" strike="noStrike">
               <a:solidFill>
@@ -10282,7 +10421,7 @@
       </p:grpSpPr>
       <p:sp>
         <p:nvSpPr>
-          <p:cNvPr id="59" name="PlaceHolder 1"/>
+          <p:cNvPr id="61" name="PlaceHolder 1"/>
           <p:cNvSpPr>
             <a:spLocks noGrp="1"/>
           </p:cNvSpPr>
@@ -10335,7 +10474,7 @@
       </p:sp>
       <p:sp>
         <p:nvSpPr>
-          <p:cNvPr id="60" name=""/>
+          <p:cNvPr id="62" name=""/>
           <p:cNvSpPr/>
           <p:nvPr/>
         </p:nvSpPr>
@@ -10372,7 +10511,7 @@
       </p:sp>
       <p:sp>
         <p:nvSpPr>
-          <p:cNvPr id="61" name=""/>
+          <p:cNvPr id="63" name=""/>
           <p:cNvSpPr/>
           <p:nvPr/>
         </p:nvSpPr>
@@ -10409,7 +10548,7 @@
       </p:sp>
       <p:sp>
         <p:nvSpPr>
-          <p:cNvPr id="62" name=""/>
+          <p:cNvPr id="64" name=""/>
           <p:cNvSpPr txBox="1"/>
           <p:nvPr/>
         </p:nvSpPr>
@@ -10460,7 +10599,7 @@
       </p:sp>
       <p:sp>
         <p:nvSpPr>
-          <p:cNvPr id="63" name=""/>
+          <p:cNvPr id="65" name=""/>
           <p:cNvSpPr txBox="1"/>
           <p:nvPr/>
         </p:nvSpPr>
@@ -10572,7 +10711,7 @@
       </p:sp>
       <p:sp>
         <p:nvSpPr>
-          <p:cNvPr id="64" name=""/>
+          <p:cNvPr id="66" name=""/>
           <p:cNvSpPr/>
           <p:nvPr/>
         </p:nvSpPr>
@@ -10609,7 +10748,7 @@
       </p:sp>
       <p:sp>
         <p:nvSpPr>
-          <p:cNvPr id="65" name=""/>
+          <p:cNvPr id="67" name=""/>
           <p:cNvSpPr/>
           <p:nvPr/>
         </p:nvSpPr>
@@ -10646,7 +10785,7 @@
       </p:sp>
       <p:sp>
         <p:nvSpPr>
-          <p:cNvPr id="66" name=""/>
+          <p:cNvPr id="68" name=""/>
           <p:cNvSpPr txBox="1"/>
           <p:nvPr/>
         </p:nvSpPr>
@@ -10697,7 +10836,7 @@
       </p:sp>
       <p:sp>
         <p:nvSpPr>
-          <p:cNvPr id="67" name=""/>
+          <p:cNvPr id="69" name=""/>
           <p:cNvSpPr txBox="1"/>
           <p:nvPr/>
         </p:nvSpPr>
@@ -10809,7 +10948,7 @@
       </p:sp>
       <p:sp>
         <p:nvSpPr>
-          <p:cNvPr id="68" name=""/>
+          <p:cNvPr id="70" name=""/>
           <p:cNvSpPr/>
           <p:nvPr/>
         </p:nvSpPr>
@@ -10846,7 +10985,7 @@
       </p:sp>
       <p:sp>
         <p:nvSpPr>
-          <p:cNvPr id="69" name=""/>
+          <p:cNvPr id="71" name=""/>
           <p:cNvSpPr/>
           <p:nvPr/>
         </p:nvSpPr>
@@ -10883,7 +11022,7 @@
       </p:sp>
       <p:sp>
         <p:nvSpPr>
-          <p:cNvPr id="70" name=""/>
+          <p:cNvPr id="72" name=""/>
           <p:cNvSpPr txBox="1"/>
           <p:nvPr/>
         </p:nvSpPr>
@@ -10934,7 +11073,7 @@
       </p:sp>
       <p:sp>
         <p:nvSpPr>
-          <p:cNvPr id="71" name=""/>
+          <p:cNvPr id="73" name=""/>
           <p:cNvSpPr txBox="1"/>
           <p:nvPr/>
         </p:nvSpPr>
@@ -11046,7 +11185,7 @@
       </p:sp>
       <p:sp>
         <p:nvSpPr>
-          <p:cNvPr id="72" name=""/>
+          <p:cNvPr id="74" name=""/>
           <p:cNvSpPr txBox="1"/>
           <p:nvPr/>
         </p:nvSpPr>
@@ -11127,7 +11266,7 @@
       </p:grpSpPr>
       <p:sp>
         <p:nvSpPr>
-          <p:cNvPr id="73" name="PlaceHolder 1"/>
+          <p:cNvPr id="75" name="PlaceHolder 1"/>
           <p:cNvSpPr>
             <a:spLocks noGrp="1"/>
           </p:cNvSpPr>
@@ -11180,7 +11319,7 @@
       </p:sp>
       <p:sp>
         <p:nvSpPr>
-          <p:cNvPr id="74" name="PlaceHolder 2"/>
+          <p:cNvPr id="76" name="PlaceHolder 2"/>
           <p:cNvSpPr>
             <a:spLocks noGrp="1"/>
           </p:cNvSpPr>
@@ -11389,7 +11528,7 @@
                 <a:uFillTx/>
                 <a:latin typeface="Calibri"/>
               </a:rPr>
-              <a:t>🗂 Kategorien</a:t>
+              <a:t>🗂 Einordnen</a:t>
             </a:r>
             <a:r>
               <a:rPr lang="de-DE" sz="2400" b="0" u="none" strike="noStrike">
@@ -11400,7 +11539,7 @@
                 <a:uFillTx/>
                 <a:latin typeface="Calibri"/>
               </a:rPr>
-              <a:t> – für alle gleich</a:t>
+              <a:t> – erst beim Teilen</a:t>
             </a:r>
             <a:endParaRPr lang="de-DE" sz="2400" b="0" u="none" strike="noStrike">
               <a:solidFill>
@@ -11434,7 +11573,7 @@
                 <a:uFillTx/>
                 <a:latin typeface="Calibri"/>
               </a:rPr>
-              <a:t>Fach und Bildungsstufe – so finden andere dein Material</a:t>
+              <a:t>Fach und Bildungsstufe im Shop – aus Tags vorgeschlagen</a:t>
             </a:r>
             <a:endParaRPr lang="de-DE" sz="1900" b="0" u="none" strike="noStrike">
               <a:solidFill>
@@ -11564,4 +11703,216 @@
     </a:fmtScheme>
   </a:themeElements>
 </a:theme>
+</file>
+
+<file path=ppt/theme/theme2.xml><?xml version="1.0" encoding="utf-8"?>
+<a:theme xmlns:a="http://schemas.openxmlformats.org/drawingml/2006/main" xmlns:r="http://schemas.openxmlformats.org/officeDocument/2006/relationships" name="Office">
+  <a:themeElements>
+    <a:clrScheme name="LibreOffice">
+      <a:dk1>
+        <a:srgbClr val="000000"/>
+      </a:dk1>
+      <a:lt1>
+        <a:srgbClr val="FFFFFF"/>
+      </a:lt1>
+      <a:dk2>
+        <a:srgbClr val="000000"/>
+      </a:dk2>
+      <a:lt2>
+        <a:srgbClr val="FFFFFF"/>
+      </a:lt2>
+      <a:accent1>
+        <a:srgbClr val="18A303"/>
+      </a:accent1>
+      <a:accent2>
+        <a:srgbClr val="0369A3"/>
+      </a:accent2>
+      <a:accent3>
+        <a:srgbClr val="A33E03"/>
+      </a:accent3>
+      <a:accent4>
+        <a:srgbClr val="8E03A3"/>
+      </a:accent4>
+      <a:accent5>
+        <a:srgbClr val="C99C00"/>
+      </a:accent5>
+      <a:accent6>
+        <a:srgbClr val="C9211E"/>
+      </a:accent6>
+      <a:hlink>
+        <a:srgbClr val="0000EE"/>
+      </a:hlink>
+      <a:folHlink>
+        <a:srgbClr val="551A8B"/>
+      </a:folHlink>
+    </a:clrScheme>
+    <a:fontScheme name="Office">
+      <a:majorFont>
+        <a:latin typeface="Arial" pitchFamily="0" charset="1"/>
+        <a:ea typeface="DejaVu Sans" pitchFamily="0" charset="1"/>
+        <a:cs typeface="DejaVu Sans" pitchFamily="0" charset="1"/>
+      </a:majorFont>
+      <a:minorFont>
+        <a:latin typeface="Arial" pitchFamily="0" charset="1"/>
+        <a:ea typeface="DejaVu Sans" pitchFamily="0" charset="1"/>
+        <a:cs typeface="DejaVu Sans" pitchFamily="0" charset="1"/>
+      </a:minorFont>
+    </a:fontScheme>
+    <a:fmtScheme>
+      <a:fillStyleLst>
+        <a:solidFill>
+          <a:schemeClr val="phClr"/>
+        </a:solidFill>
+        <a:solidFill>
+          <a:schemeClr val="phClr"/>
+        </a:solidFill>
+        <a:solidFill>
+          <a:schemeClr val="phClr"/>
+        </a:solidFill>
+      </a:fillStyleLst>
+      <a:lnStyleLst>
+        <a:ln w="6350" cap="flat" cmpd="sng" algn="ctr">
+          <a:prstDash val="solid"/>
+          <a:miter/>
+        </a:ln>
+        <a:ln w="6350" cap="flat" cmpd="sng" algn="ctr">
+          <a:prstDash val="solid"/>
+          <a:miter/>
+        </a:ln>
+        <a:ln w="6350" cap="flat" cmpd="sng" algn="ctr">
+          <a:prstDash val="solid"/>
+          <a:miter/>
+        </a:ln>
+      </a:lnStyleLst>
+      <a:effectStyleLst>
+        <a:effectStyle>
+          <a:effectLst/>
+        </a:effectStyle>
+        <a:effectStyle>
+          <a:effectLst/>
+        </a:effectStyle>
+        <a:effectStyle>
+          <a:effectLst/>
+        </a:effectStyle>
+      </a:effectStyleLst>
+      <a:bgFillStyleLst>
+        <a:solidFill>
+          <a:schemeClr val="phClr"/>
+        </a:solidFill>
+        <a:solidFill>
+          <a:schemeClr val="phClr"/>
+        </a:solidFill>
+        <a:solidFill>
+          <a:schemeClr val="phClr"/>
+        </a:solidFill>
+      </a:bgFillStyleLst>
+    </a:fmtScheme>
+  </a:themeElements>
+</a:theme>
+</file>
+
+<file path=ppt/theme/theme3.xml><?xml version="1.0" encoding="utf-8"?>
+<a:theme xmlns:a="http://schemas.openxmlformats.org/drawingml/2006/main" xmlns:r="http://schemas.openxmlformats.org/officeDocument/2006/relationships" name="Office">
+  <a:themeElements>
+    <a:clrScheme name="LibreOffice">
+      <a:dk1>
+        <a:srgbClr val="000000"/>
+      </a:dk1>
+      <a:lt1>
+        <a:srgbClr val="FFFFFF"/>
+      </a:lt1>
+      <a:dk2>
+        <a:srgbClr val="000000"/>
+      </a:dk2>
+      <a:lt2>
+        <a:srgbClr val="FFFFFF"/>
+      </a:lt2>
+      <a:accent1>
+        <a:srgbClr val="18A303"/>
+      </a:accent1>
+      <a:accent2>
+        <a:srgbClr val="0369A3"/>
+      </a:accent2>
+      <a:accent3>
+        <a:srgbClr val="A33E03"/>
+      </a:accent3>
+      <a:accent4>
+        <a:srgbClr val="8E03A3"/>
+      </a:accent4>
+      <a:accent5>
+        <a:srgbClr val="C99C00"/>
+      </a:accent5>
+      <a:accent6>
+        <a:srgbClr val="C9211E"/>
+      </a:accent6>
+      <a:hlink>
+        <a:srgbClr val="0000EE"/>
+      </a:hlink>
+      <a:folHlink>
+        <a:srgbClr val="551A8B"/>
+      </a:folHlink>
+    </a:clrScheme>
+    <a:fontScheme name="Office">
+      <a:majorFont>
+        <a:latin typeface="Arial" pitchFamily="0" charset="1"/>
+        <a:ea typeface="DejaVu Sans" pitchFamily="0" charset="1"/>
+        <a:cs typeface="DejaVu Sans" pitchFamily="0" charset="1"/>
+      </a:majorFont>
+      <a:minorFont>
+        <a:latin typeface="Arial" pitchFamily="0" charset="1"/>
+        <a:ea typeface="DejaVu Sans" pitchFamily="0" charset="1"/>
+        <a:cs typeface="DejaVu Sans" pitchFamily="0" charset="1"/>
+      </a:minorFont>
+    </a:fontScheme>
+    <a:fmtScheme>
+      <a:fillStyleLst>
+        <a:solidFill>
+          <a:schemeClr val="phClr"/>
+        </a:solidFill>
+        <a:solidFill>
+          <a:schemeClr val="phClr"/>
+        </a:solidFill>
+        <a:solidFill>
+          <a:schemeClr val="phClr"/>
+        </a:solidFill>
+      </a:fillStyleLst>
+      <a:lnStyleLst>
+        <a:ln w="6350" cap="flat" cmpd="sng" algn="ctr">
+          <a:prstDash val="solid"/>
+          <a:miter/>
+        </a:ln>
+        <a:ln w="6350" cap="flat" cmpd="sng" algn="ctr">
+          <a:prstDash val="solid"/>
+          <a:miter/>
+        </a:ln>
+        <a:ln w="6350" cap="flat" cmpd="sng" algn="ctr">
+          <a:prstDash val="solid"/>
+          <a:miter/>
+        </a:ln>
+      </a:lnStyleLst>
+      <a:effectStyleLst>
+        <a:effectStyle>
+          <a:effectLst/>
+        </a:effectStyle>
+        <a:effectStyle>
+          <a:effectLst/>
+        </a:effectStyle>
+        <a:effectStyle>
+          <a:effectLst/>
+        </a:effectStyle>
+      </a:effectStyleLst>
+      <a:bgFillStyleLst>
+        <a:solidFill>
+          <a:schemeClr val="phClr"/>
+        </a:solidFill>
+        <a:solidFill>
+          <a:schemeClr val="phClr"/>
+        </a:solidFill>
+        <a:solidFill>
+          <a:schemeClr val="phClr"/>
+        </a:solidFill>
+      </a:bgFillStyleLst>
+    </a:fmtScheme>
+  </a:themeElements>
+</a:theme>
 </file>
</xml_diff>